<commit_message>
updated project with new changes
</commit_message>
<xml_diff>
--- a/output.pptx
+++ b/output.pptx
@@ -10,8 +10,10 @@
     <p:sldId id="258" r:id="rId9"/>
     <p:sldId id="259" r:id="rId10"/>
     <p:sldId id="260" r:id="rId11"/>
+    <p:sldId id="261" r:id="rId12"/>
+    <p:sldId id="262" r:id="rId13"/>
   </p:sldIdLst>
-  <p:sldSz cx="9144000" cy="6858000" type="screen4x3"/>
+  <p:sldSz cx="12188952" cy="6858000" type="screen4x3"/>
   <p:notesSz cx="6858000" cy="9144000"/>
   <p:defaultTextStyle>
     <a:defPPr>
@@ -3085,6 +3087,14 @@
 <file path=ppt/slides/slide1.xml><?xml version="1.0" encoding="utf-8"?>
 <p:sld xmlns:a="http://schemas.openxmlformats.org/drawingml/2006/main" xmlns:p="http://schemas.openxmlformats.org/presentationml/2006/main" xmlns:r="http://schemas.openxmlformats.org/officeDocument/2006/relationships">
   <p:cSld>
+    <p:bg>
+      <p:bgPr>
+        <a:solidFill>
+          <a:srgbClr val="0D1B2A"/>
+        </a:solidFill>
+        <a:effectLst/>
+      </p:bgPr>
+    </p:bg>
     <p:spTree>
       <p:nvGrpSpPr>
         <p:cNvPr id="1" name=""/>
@@ -3094,55 +3104,111 @@
       <p:grpSpPr/>
       <p:sp>
         <p:nvSpPr>
-          <p:cNvPr id="2" name="Title 1"/>
-          <p:cNvSpPr>
-            <a:spLocks noGrp="1"/>
-          </p:cNvSpPr>
-          <p:nvPr>
-            <p:ph type="title"/>
-          </p:nvPr>
-        </p:nvSpPr>
-        <p:spPr/>
-        <p:txBody>
-          <a:bodyPr/>
-          <a:lstStyle/>
-          <a:p>
-            <a:r>
-              <a:t>Introduction to Stars</a:t>
-            </a:r>
-          </a:p>
-        </p:txBody>
-      </p:sp>
-      <p:sp>
-        <p:nvSpPr>
-          <p:cNvPr id="3" name="Content Placeholder 2"/>
-          <p:cNvSpPr>
-            <a:spLocks noGrp="1"/>
-          </p:cNvSpPr>
-          <p:nvPr>
-            <p:ph idx="1"/>
-          </p:nvPr>
-        </p:nvSpPr>
-        <p:spPr/>
-        <p:txBody>
-          <a:bodyPr/>
-          <a:lstStyle/>
-          <a:p>
-            <a:pPr/>
-            <a:r>
-              <a:t>A star is a massive, luminous sphere of plasma held together by its own gravity.</a:t>
-            </a:r>
-          </a:p>
-          <a:p>
-            <a:pPr/>
-            <a:r>
-              <a:t>The life cycle of a star is the sequence of stages a star undergoes from its formation to its death.</a:t>
-            </a:r>
-          </a:p>
-          <a:p>
-            <a:pPr/>
-            <a:r>
-              <a:t>The life cycle of a star depends on its mass.</a:t>
+          <p:cNvPr id="2" name="Rectangle 1"/>
+          <p:cNvSpPr/>
+          <p:nvPr/>
+        </p:nvSpPr>
+        <p:spPr>
+          <a:xfrm>
+            <a:off x="0" y="0"/>
+            <a:ext cx="137160" cy="6858000"/>
+          </a:xfrm>
+          <a:prstGeom prst="rect">
+            <a:avLst/>
+          </a:prstGeom>
+          <a:solidFill>
+            <a:srgbClr val="00B4D8"/>
+          </a:solidFill>
+          <a:ln>
+            <a:noFill/>
+          </a:ln>
+        </p:spPr>
+        <p:style>
+          <a:lnRef idx="1">
+            <a:schemeClr val="accent1"/>
+          </a:lnRef>
+          <a:fillRef idx="3">
+            <a:schemeClr val="accent1"/>
+          </a:fillRef>
+          <a:effectRef idx="2">
+            <a:schemeClr val="accent1"/>
+          </a:effectRef>
+          <a:fontRef idx="minor">
+            <a:schemeClr val="lt1"/>
+          </a:fontRef>
+        </p:style>
+        <p:txBody>
+          <a:bodyPr rtlCol="0" anchor="ctr"/>
+          <a:lstStyle/>
+          <a:p>
+            <a:pPr algn="ctr"/>
+          </a:p>
+        </p:txBody>
+      </p:sp>
+      <p:sp>
+        <p:nvSpPr>
+          <p:cNvPr id="3" name="TextBox 2"/>
+          <p:cNvSpPr txBox="1"/>
+          <p:nvPr/>
+        </p:nvSpPr>
+        <p:spPr>
+          <a:xfrm>
+            <a:off x="457200" y="2011680"/>
+            <a:ext cx="10972800" cy="1371600"/>
+          </a:xfrm>
+          <a:prstGeom prst="rect">
+            <a:avLst/>
+          </a:prstGeom>
+          <a:noFill/>
+        </p:spPr>
+        <p:txBody>
+          <a:bodyPr wrap="square">
+            <a:spAutoFit/>
+          </a:bodyPr>
+          <a:lstStyle/>
+          <a:p>
+            <a:pPr algn="ctr"/>
+            <a:r>
+              <a:rPr sz="4400" b="1">
+                <a:solidFill>
+                  <a:srgbClr val="FFFFFF"/>
+                </a:solidFill>
+              </a:rPr>
+              <a:t>Operating System Concepts Overview</a:t>
+            </a:r>
+          </a:p>
+        </p:txBody>
+      </p:sp>
+      <p:sp>
+        <p:nvSpPr>
+          <p:cNvPr id="4" name="TextBox 3"/>
+          <p:cNvSpPr txBox="1"/>
+          <p:nvPr/>
+        </p:nvSpPr>
+        <p:spPr>
+          <a:xfrm>
+            <a:off x="457200" y="3474720"/>
+            <a:ext cx="10972800" cy="914400"/>
+          </a:xfrm>
+          <a:prstGeom prst="rect">
+            <a:avLst/>
+          </a:prstGeom>
+          <a:noFill/>
+        </p:spPr>
+        <p:txBody>
+          <a:bodyPr wrap="square">
+            <a:spAutoFit/>
+          </a:bodyPr>
+          <a:lstStyle/>
+          <a:p>
+            <a:pPr algn="ctr"/>
+            <a:r>
+              <a:rPr sz="2200" b="0">
+                <a:solidFill>
+                  <a:srgbClr val="00B4D8"/>
+                </a:solidFill>
+              </a:rPr>
+              <a:t>Understanding the fundamentals of operating systems</a:t>
             </a:r>
           </a:p>
         </p:txBody>
@@ -3158,6 +3224,14 @@
 <file path=ppt/slides/slide2.xml><?xml version="1.0" encoding="utf-8"?>
 <p:sld xmlns:a="http://schemas.openxmlformats.org/drawingml/2006/main" xmlns:p="http://schemas.openxmlformats.org/presentationml/2006/main" xmlns:r="http://schemas.openxmlformats.org/officeDocument/2006/relationships">
   <p:cSld>
+    <p:bg>
+      <p:bgPr>
+        <a:solidFill>
+          <a:srgbClr val="0D1B2A"/>
+        </a:solidFill>
+        <a:effectLst/>
+      </p:bgPr>
+    </p:bg>
     <p:spTree>
       <p:nvGrpSpPr>
         <p:cNvPr id="1" name=""/>
@@ -3167,59 +3241,143 @@
       <p:grpSpPr/>
       <p:sp>
         <p:nvSpPr>
-          <p:cNvPr id="2" name="Title 1"/>
-          <p:cNvSpPr>
-            <a:spLocks noGrp="1"/>
-          </p:cNvSpPr>
-          <p:nvPr>
-            <p:ph type="title"/>
-          </p:nvPr>
-        </p:nvSpPr>
-        <p:spPr/>
-        <p:txBody>
-          <a:bodyPr/>
-          <a:lstStyle/>
-          <a:p>
-            <a:r>
-              <a:t>Protostar Formation</a:t>
-            </a:r>
-          </a:p>
-        </p:txBody>
-      </p:sp>
-      <p:sp>
-        <p:nvSpPr>
-          <p:cNvPr id="3" name="Content Placeholder 2"/>
-          <p:cNvSpPr>
-            <a:spLocks noGrp="1"/>
-          </p:cNvSpPr>
-          <p:nvPr>
-            <p:ph idx="1"/>
-          </p:nvPr>
-        </p:nvSpPr>
-        <p:spPr/>
-        <p:txBody>
-          <a:bodyPr/>
-          <a:lstStyle/>
-          <a:p>
-            <a:pPr/>
-            <a:r>
-              <a:t>A star forms from a giant molecular cloud.</a:t>
-            </a:r>
-          </a:p>
-          <a:p>
-            <a:pPr/>
-            <a:r>
-              <a:t>As the cloud collapses, it begins to spin faster and faster.</a:t>
-            </a:r>
-          </a:p>
-          <a:p>
-            <a:pPr/>
-            <a:r>
-              <a:t>The conservation of angular momentum causes the cloud to flatten into a disk shape.</a:t>
-            </a:r>
-          </a:p>
-        </p:txBody>
-      </p:sp>
+          <p:cNvPr id="2" name="Rectangle 1"/>
+          <p:cNvSpPr/>
+          <p:nvPr/>
+        </p:nvSpPr>
+        <p:spPr>
+          <a:xfrm>
+            <a:off x="0" y="0"/>
+            <a:ext cx="12188952" cy="73152"/>
+          </a:xfrm>
+          <a:prstGeom prst="rect">
+            <a:avLst/>
+          </a:prstGeom>
+          <a:solidFill>
+            <a:srgbClr val="00B4D8"/>
+          </a:solidFill>
+          <a:ln>
+            <a:noFill/>
+          </a:ln>
+        </p:spPr>
+        <p:style>
+          <a:lnRef idx="1">
+            <a:schemeClr val="accent1"/>
+          </a:lnRef>
+          <a:fillRef idx="3">
+            <a:schemeClr val="accent1"/>
+          </a:fillRef>
+          <a:effectRef idx="2">
+            <a:schemeClr val="accent1"/>
+          </a:effectRef>
+          <a:fontRef idx="minor">
+            <a:schemeClr val="lt1"/>
+          </a:fontRef>
+        </p:style>
+        <p:txBody>
+          <a:bodyPr rtlCol="0" anchor="ctr"/>
+          <a:lstStyle/>
+          <a:p>
+            <a:pPr algn="ctr"/>
+          </a:p>
+        </p:txBody>
+      </p:sp>
+      <p:sp>
+        <p:nvSpPr>
+          <p:cNvPr id="3" name="TextBox 2"/>
+          <p:cNvSpPr txBox="1"/>
+          <p:nvPr/>
+        </p:nvSpPr>
+        <p:spPr>
+          <a:xfrm>
+            <a:off x="365760" y="137160"/>
+            <a:ext cx="6858000" cy="731520"/>
+          </a:xfrm>
+          <a:prstGeom prst="rect">
+            <a:avLst/>
+          </a:prstGeom>
+          <a:noFill/>
+        </p:spPr>
+        <p:txBody>
+          <a:bodyPr wrap="square">
+            <a:spAutoFit/>
+          </a:bodyPr>
+          <a:lstStyle/>
+          <a:p>
+            <a:pPr algn="l"/>
+            <a:r>
+              <a:rPr sz="2800" b="1">
+                <a:solidFill>
+                  <a:srgbClr val="FFFFFF"/>
+                </a:solidFill>
+              </a:rPr>
+              <a:t>Introduction to Operating Systems</a:t>
+            </a:r>
+          </a:p>
+        </p:txBody>
+      </p:sp>
+      <p:sp>
+        <p:nvSpPr>
+          <p:cNvPr id="4" name="TextBox 3"/>
+          <p:cNvSpPr txBox="1"/>
+          <p:nvPr/>
+        </p:nvSpPr>
+        <p:spPr>
+          <a:xfrm>
+            <a:off x="365760" y="1005840"/>
+            <a:ext cx="5943600" cy="5303520"/>
+          </a:xfrm>
+          <a:prstGeom prst="rect">
+            <a:avLst/>
+          </a:prstGeom>
+          <a:noFill/>
+        </p:spPr>
+        <p:txBody>
+          <a:bodyPr wrap="square">
+            <a:spAutoFit/>
+          </a:bodyPr>
+          <a:lstStyle/>
+          <a:p>
+            <a:pPr algn="l"/>
+            <a:r>
+              <a:rPr sz="2200" b="0">
+                <a:solidFill>
+                  <a:srgbClr val="CAD3E0"/>
+                </a:solidFill>
+              </a:rPr>
+              <a:t>• Operating systems manage computer hardware resources efficiently always
+• Providing a platform for running application software seamlessly always
+• Controlling input output devices and memory allocation effectively
+• Enabling multitasking and multithreading capabilities simultaneously
+• Supporting various file systems and storage devices securely</a:t>
+            </a:r>
+          </a:p>
+        </p:txBody>
+      </p:sp>
+      <p:pic>
+        <p:nvPicPr>
+          <p:cNvPr id="5" name="Picture 4" descr="tmpgtr4f9pk.jpg"/>
+          <p:cNvPicPr>
+            <a:picLocks noChangeAspect="1"/>
+          </p:cNvPicPr>
+          <p:nvPr/>
+        </p:nvPicPr>
+        <p:blipFill>
+          <a:blip r:embed="rId2"/>
+          <a:stretch>
+            <a:fillRect/>
+          </a:stretch>
+        </p:blipFill>
+        <p:spPr>
+          <a:xfrm>
+            <a:off x="6583680" y="822960"/>
+            <a:ext cx="5212080" cy="5303520"/>
+          </a:xfrm>
+          <a:prstGeom prst="rect">
+            <a:avLst/>
+          </a:prstGeom>
+        </p:spPr>
+      </p:pic>
     </p:spTree>
   </p:cSld>
   <p:clrMapOvr>
@@ -3231,6 +3389,14 @@
 <file path=ppt/slides/slide3.xml><?xml version="1.0" encoding="utf-8"?>
 <p:sld xmlns:a="http://schemas.openxmlformats.org/drawingml/2006/main" xmlns:p="http://schemas.openxmlformats.org/presentationml/2006/main" xmlns:r="http://schemas.openxmlformats.org/officeDocument/2006/relationships">
   <p:cSld>
+    <p:bg>
+      <p:bgPr>
+        <a:solidFill>
+          <a:srgbClr val="0D1B2A"/>
+        </a:solidFill>
+        <a:effectLst/>
+      </p:bgPr>
+    </p:bg>
     <p:spTree>
       <p:nvGrpSpPr>
         <p:cNvPr id="1" name=""/>
@@ -3240,59 +3406,143 @@
       <p:grpSpPr/>
       <p:sp>
         <p:nvSpPr>
-          <p:cNvPr id="2" name="Title 1"/>
-          <p:cNvSpPr>
-            <a:spLocks noGrp="1"/>
-          </p:cNvSpPr>
-          <p:nvPr>
-            <p:ph type="title"/>
-          </p:nvPr>
-        </p:nvSpPr>
-        <p:spPr/>
-        <p:txBody>
-          <a:bodyPr/>
-          <a:lstStyle/>
-          <a:p>
-            <a:r>
-              <a:t>Main Sequence</a:t>
-            </a:r>
-          </a:p>
-        </p:txBody>
-      </p:sp>
-      <p:sp>
-        <p:nvSpPr>
-          <p:cNvPr id="3" name="Content Placeholder 2"/>
-          <p:cNvSpPr>
-            <a:spLocks noGrp="1"/>
-          </p:cNvSpPr>
-          <p:nvPr>
-            <p:ph idx="1"/>
-          </p:nvPr>
-        </p:nvSpPr>
-        <p:spPr/>
-        <p:txBody>
-          <a:bodyPr/>
-          <a:lstStyle/>
-          <a:p>
-            <a:pPr/>
-            <a:r>
-              <a:t>The star reaches the main sequence stage, where it fuses hydrogen into helium in its core.</a:t>
-            </a:r>
-          </a:p>
-          <a:p>
-            <a:pPr/>
-            <a:r>
-              <a:t>This is the longest stage of a star's life cycle.</a:t>
-            </a:r>
-          </a:p>
-          <a:p>
-            <a:pPr/>
-            <a:r>
-              <a:t>The star will remain in this stage for millions or billions of years, depending on its mass.</a:t>
-            </a:r>
-          </a:p>
-        </p:txBody>
-      </p:sp>
+          <p:cNvPr id="2" name="Rectangle 1"/>
+          <p:cNvSpPr/>
+          <p:nvPr/>
+        </p:nvSpPr>
+        <p:spPr>
+          <a:xfrm>
+            <a:off x="0" y="0"/>
+            <a:ext cx="12188952" cy="73152"/>
+          </a:xfrm>
+          <a:prstGeom prst="rect">
+            <a:avLst/>
+          </a:prstGeom>
+          <a:solidFill>
+            <a:srgbClr val="00B4D8"/>
+          </a:solidFill>
+          <a:ln>
+            <a:noFill/>
+          </a:ln>
+        </p:spPr>
+        <p:style>
+          <a:lnRef idx="1">
+            <a:schemeClr val="accent1"/>
+          </a:lnRef>
+          <a:fillRef idx="3">
+            <a:schemeClr val="accent1"/>
+          </a:fillRef>
+          <a:effectRef idx="2">
+            <a:schemeClr val="accent1"/>
+          </a:effectRef>
+          <a:fontRef idx="minor">
+            <a:schemeClr val="lt1"/>
+          </a:fontRef>
+        </p:style>
+        <p:txBody>
+          <a:bodyPr rtlCol="0" anchor="ctr"/>
+          <a:lstStyle/>
+          <a:p>
+            <a:pPr algn="ctr"/>
+          </a:p>
+        </p:txBody>
+      </p:sp>
+      <p:sp>
+        <p:nvSpPr>
+          <p:cNvPr id="3" name="TextBox 2"/>
+          <p:cNvSpPr txBox="1"/>
+          <p:nvPr/>
+        </p:nvSpPr>
+        <p:spPr>
+          <a:xfrm>
+            <a:off x="365760" y="137160"/>
+            <a:ext cx="6858000" cy="731520"/>
+          </a:xfrm>
+          <a:prstGeom prst="rect">
+            <a:avLst/>
+          </a:prstGeom>
+          <a:noFill/>
+        </p:spPr>
+        <p:txBody>
+          <a:bodyPr wrap="square">
+            <a:spAutoFit/>
+          </a:bodyPr>
+          <a:lstStyle/>
+          <a:p>
+            <a:pPr algn="l"/>
+            <a:r>
+              <a:rPr sz="2800" b="1">
+                <a:solidFill>
+                  <a:srgbClr val="FFFFFF"/>
+                </a:solidFill>
+              </a:rPr>
+              <a:t>Process Management Concepts</a:t>
+            </a:r>
+          </a:p>
+        </p:txBody>
+      </p:sp>
+      <p:sp>
+        <p:nvSpPr>
+          <p:cNvPr id="4" name="TextBox 3"/>
+          <p:cNvSpPr txBox="1"/>
+          <p:nvPr/>
+        </p:nvSpPr>
+        <p:spPr>
+          <a:xfrm>
+            <a:off x="365760" y="1005840"/>
+            <a:ext cx="5943600" cy="5303520"/>
+          </a:xfrm>
+          <a:prstGeom prst="rect">
+            <a:avLst/>
+          </a:prstGeom>
+          <a:noFill/>
+        </p:spPr>
+        <p:txBody>
+          <a:bodyPr wrap="square">
+            <a:spAutoFit/>
+          </a:bodyPr>
+          <a:lstStyle/>
+          <a:p>
+            <a:pPr algn="l"/>
+            <a:r>
+              <a:rPr sz="2200" b="0">
+                <a:solidFill>
+                  <a:srgbClr val="CAD3E0"/>
+                </a:solidFill>
+              </a:rPr>
+              <a:t>• Processes are independent units of execution and computation always
+• Threads are lightweight processes sharing resources efficiently always
+• Context switching enables process scheduling and switching quickly
+• Synchronization mechanisms prevent data inconsistencies always
+• Deadlock prevention and avoidance techniques are essential always</a:t>
+            </a:r>
+          </a:p>
+        </p:txBody>
+      </p:sp>
+      <p:pic>
+        <p:nvPicPr>
+          <p:cNvPr id="5" name="Picture 4" descr="tmpe9_p2qfv.jpg"/>
+          <p:cNvPicPr>
+            <a:picLocks noChangeAspect="1"/>
+          </p:cNvPicPr>
+          <p:nvPr/>
+        </p:nvPicPr>
+        <p:blipFill>
+          <a:blip r:embed="rId2"/>
+          <a:stretch>
+            <a:fillRect/>
+          </a:stretch>
+        </p:blipFill>
+        <p:spPr>
+          <a:xfrm>
+            <a:off x="6583680" y="822960"/>
+            <a:ext cx="5212080" cy="5303520"/>
+          </a:xfrm>
+          <a:prstGeom prst="rect">
+            <a:avLst/>
+          </a:prstGeom>
+        </p:spPr>
+      </p:pic>
     </p:spTree>
   </p:cSld>
   <p:clrMapOvr>
@@ -3304,6 +3554,14 @@
 <file path=ppt/slides/slide4.xml><?xml version="1.0" encoding="utf-8"?>
 <p:sld xmlns:a="http://schemas.openxmlformats.org/drawingml/2006/main" xmlns:p="http://schemas.openxmlformats.org/presentationml/2006/main" xmlns:r="http://schemas.openxmlformats.org/officeDocument/2006/relationships">
   <p:cSld>
+    <p:bg>
+      <p:bgPr>
+        <a:solidFill>
+          <a:srgbClr val="0D1B2A"/>
+        </a:solidFill>
+        <a:effectLst/>
+      </p:bgPr>
+    </p:bg>
     <p:spTree>
       <p:nvGrpSpPr>
         <p:cNvPr id="1" name=""/>
@@ -3313,59 +3571,143 @@
       <p:grpSpPr/>
       <p:sp>
         <p:nvSpPr>
-          <p:cNvPr id="2" name="Title 1"/>
-          <p:cNvSpPr>
-            <a:spLocks noGrp="1"/>
-          </p:cNvSpPr>
-          <p:nvPr>
-            <p:ph type="title"/>
-          </p:nvPr>
-        </p:nvSpPr>
-        <p:spPr/>
-        <p:txBody>
-          <a:bodyPr/>
-          <a:lstStyle/>
-          <a:p>
-            <a:r>
-              <a:t>Red Giant and White Dwarf</a:t>
-            </a:r>
-          </a:p>
-        </p:txBody>
-      </p:sp>
-      <p:sp>
-        <p:nvSpPr>
-          <p:cNvPr id="3" name="Content Placeholder 2"/>
-          <p:cNvSpPr>
-            <a:spLocks noGrp="1"/>
-          </p:cNvSpPr>
-          <p:nvPr>
-            <p:ph idx="1"/>
-          </p:nvPr>
-        </p:nvSpPr>
-        <p:spPr/>
-        <p:txBody>
-          <a:bodyPr/>
-          <a:lstStyle/>
-          <a:p>
-            <a:pPr/>
-            <a:r>
-              <a:t>As the star runs out of hydrogen fuel, it expands into a red giant.</a:t>
-            </a:r>
-          </a:p>
-          <a:p>
-            <a:pPr/>
-            <a:r>
-              <a:t>The star then sheds its outer layers, leaving behind a white dwarf.</a:t>
-            </a:r>
-          </a:p>
-          <a:p>
-            <a:pPr/>
-            <a:r>
-              <a:t>The white dwarf will slowly cool over time, eventually becoming a black dwarf.</a:t>
-            </a:r>
-          </a:p>
-        </p:txBody>
-      </p:sp>
+          <p:cNvPr id="2" name="Rectangle 1"/>
+          <p:cNvSpPr/>
+          <p:nvPr/>
+        </p:nvSpPr>
+        <p:spPr>
+          <a:xfrm>
+            <a:off x="0" y="0"/>
+            <a:ext cx="12188952" cy="73152"/>
+          </a:xfrm>
+          <a:prstGeom prst="rect">
+            <a:avLst/>
+          </a:prstGeom>
+          <a:solidFill>
+            <a:srgbClr val="00B4D8"/>
+          </a:solidFill>
+          <a:ln>
+            <a:noFill/>
+          </a:ln>
+        </p:spPr>
+        <p:style>
+          <a:lnRef idx="1">
+            <a:schemeClr val="accent1"/>
+          </a:lnRef>
+          <a:fillRef idx="3">
+            <a:schemeClr val="accent1"/>
+          </a:fillRef>
+          <a:effectRef idx="2">
+            <a:schemeClr val="accent1"/>
+          </a:effectRef>
+          <a:fontRef idx="minor">
+            <a:schemeClr val="lt1"/>
+          </a:fontRef>
+        </p:style>
+        <p:txBody>
+          <a:bodyPr rtlCol="0" anchor="ctr"/>
+          <a:lstStyle/>
+          <a:p>
+            <a:pPr algn="ctr"/>
+          </a:p>
+        </p:txBody>
+      </p:sp>
+      <p:sp>
+        <p:nvSpPr>
+          <p:cNvPr id="3" name="TextBox 2"/>
+          <p:cNvSpPr txBox="1"/>
+          <p:nvPr/>
+        </p:nvSpPr>
+        <p:spPr>
+          <a:xfrm>
+            <a:off x="365760" y="137160"/>
+            <a:ext cx="6858000" cy="731520"/>
+          </a:xfrm>
+          <a:prstGeom prst="rect">
+            <a:avLst/>
+          </a:prstGeom>
+          <a:noFill/>
+        </p:spPr>
+        <p:txBody>
+          <a:bodyPr wrap="square">
+            <a:spAutoFit/>
+          </a:bodyPr>
+          <a:lstStyle/>
+          <a:p>
+            <a:pPr algn="l"/>
+            <a:r>
+              <a:rPr sz="2800" b="1">
+                <a:solidFill>
+                  <a:srgbClr val="FFFFFF"/>
+                </a:solidFill>
+              </a:rPr>
+              <a:t>Memory Management Techniques</a:t>
+            </a:r>
+          </a:p>
+        </p:txBody>
+      </p:sp>
+      <p:sp>
+        <p:nvSpPr>
+          <p:cNvPr id="4" name="TextBox 3"/>
+          <p:cNvSpPr txBox="1"/>
+          <p:nvPr/>
+        </p:nvSpPr>
+        <p:spPr>
+          <a:xfrm>
+            <a:off x="365760" y="1005840"/>
+            <a:ext cx="5943600" cy="5303520"/>
+          </a:xfrm>
+          <a:prstGeom prst="rect">
+            <a:avLst/>
+          </a:prstGeom>
+          <a:noFill/>
+        </p:spPr>
+        <p:txBody>
+          <a:bodyPr wrap="square">
+            <a:spAutoFit/>
+          </a:bodyPr>
+          <a:lstStyle/>
+          <a:p>
+            <a:pPr algn="l"/>
+            <a:r>
+              <a:rPr sz="2200" b="0">
+                <a:solidFill>
+                  <a:srgbClr val="CAD3E0"/>
+                </a:solidFill>
+              </a:rPr>
+              <a:t>• Memory allocation and deallocation are critical system functions always
+• Paging and segmentation enable efficient memory utilization always
+• Virtual memory extends physical memory capacity effectively always
+• Cache memory improves system performance significantly always
+• Memory protection mechanisms prevent data corruption always</a:t>
+            </a:r>
+          </a:p>
+        </p:txBody>
+      </p:sp>
+      <p:pic>
+        <p:nvPicPr>
+          <p:cNvPr id="5" name="Picture 4" descr="tmpkuvustlh.jpg"/>
+          <p:cNvPicPr>
+            <a:picLocks noChangeAspect="1"/>
+          </p:cNvPicPr>
+          <p:nvPr/>
+        </p:nvPicPr>
+        <p:blipFill>
+          <a:blip r:embed="rId2"/>
+          <a:stretch>
+            <a:fillRect/>
+          </a:stretch>
+        </p:blipFill>
+        <p:spPr>
+          <a:xfrm>
+            <a:off x="6583680" y="822960"/>
+            <a:ext cx="5212080" cy="5303520"/>
+          </a:xfrm>
+          <a:prstGeom prst="rect">
+            <a:avLst/>
+          </a:prstGeom>
+        </p:spPr>
+      </p:pic>
     </p:spTree>
   </p:cSld>
   <p:clrMapOvr>
@@ -3377,6 +3719,14 @@
 <file path=ppt/slides/slide5.xml><?xml version="1.0" encoding="utf-8"?>
 <p:sld xmlns:a="http://schemas.openxmlformats.org/drawingml/2006/main" xmlns:p="http://schemas.openxmlformats.org/presentationml/2006/main" xmlns:r="http://schemas.openxmlformats.org/officeDocument/2006/relationships">
   <p:cSld>
+    <p:bg>
+      <p:bgPr>
+        <a:solidFill>
+          <a:srgbClr val="0D1B2A"/>
+        </a:solidFill>
+        <a:effectLst/>
+      </p:bgPr>
+    </p:bg>
     <p:spTree>
       <p:nvGrpSpPr>
         <p:cNvPr id="1" name=""/>
@@ -3386,55 +3736,477 @@
       <p:grpSpPr/>
       <p:sp>
         <p:nvSpPr>
-          <p:cNvPr id="2" name="Title 1"/>
-          <p:cNvSpPr>
-            <a:spLocks noGrp="1"/>
-          </p:cNvSpPr>
-          <p:nvPr>
-            <p:ph type="title"/>
-          </p:nvPr>
-        </p:nvSpPr>
-        <p:spPr/>
-        <p:txBody>
-          <a:bodyPr/>
-          <a:lstStyle/>
-          <a:p>
-            <a:r>
-              <a:t>Supernova and Black Hole</a:t>
-            </a:r>
-          </a:p>
-        </p:txBody>
-      </p:sp>
-      <p:sp>
-        <p:nvSpPr>
-          <p:cNvPr id="3" name="Content Placeholder 2"/>
-          <p:cNvSpPr>
-            <a:spLocks noGrp="1"/>
-          </p:cNvSpPr>
-          <p:nvPr>
-            <p:ph idx="1"/>
-          </p:nvPr>
-        </p:nvSpPr>
-        <p:spPr/>
-        <p:txBody>
-          <a:bodyPr/>
-          <a:lstStyle/>
-          <a:p>
-            <a:pPr/>
-            <a:r>
-              <a:t>If the star is massive enough, it will end its life in a supernova explosion.</a:t>
-            </a:r>
-          </a:p>
-          <a:p>
-            <a:pPr/>
-            <a:r>
-              <a:t>The supernova explosion can be so powerful that it is visible from millions of light-years away.</a:t>
-            </a:r>
-          </a:p>
-          <a:p>
-            <a:pPr/>
-            <a:r>
-              <a:t>After the supernova, the star may leave behind either a neutron star or a black hole, depending on its mass.</a:t>
+          <p:cNvPr id="2" name="Rectangle 1"/>
+          <p:cNvSpPr/>
+          <p:nvPr/>
+        </p:nvSpPr>
+        <p:spPr>
+          <a:xfrm>
+            <a:off x="0" y="0"/>
+            <a:ext cx="12188952" cy="73152"/>
+          </a:xfrm>
+          <a:prstGeom prst="rect">
+            <a:avLst/>
+          </a:prstGeom>
+          <a:solidFill>
+            <a:srgbClr val="00B4D8"/>
+          </a:solidFill>
+          <a:ln>
+            <a:noFill/>
+          </a:ln>
+        </p:spPr>
+        <p:style>
+          <a:lnRef idx="1">
+            <a:schemeClr val="accent1"/>
+          </a:lnRef>
+          <a:fillRef idx="3">
+            <a:schemeClr val="accent1"/>
+          </a:fillRef>
+          <a:effectRef idx="2">
+            <a:schemeClr val="accent1"/>
+          </a:effectRef>
+          <a:fontRef idx="minor">
+            <a:schemeClr val="lt1"/>
+          </a:fontRef>
+        </p:style>
+        <p:txBody>
+          <a:bodyPr rtlCol="0" anchor="ctr"/>
+          <a:lstStyle/>
+          <a:p>
+            <a:pPr algn="ctr"/>
+          </a:p>
+        </p:txBody>
+      </p:sp>
+      <p:sp>
+        <p:nvSpPr>
+          <p:cNvPr id="3" name="TextBox 2"/>
+          <p:cNvSpPr txBox="1"/>
+          <p:nvPr/>
+        </p:nvSpPr>
+        <p:spPr>
+          <a:xfrm>
+            <a:off x="365760" y="137160"/>
+            <a:ext cx="6858000" cy="731520"/>
+          </a:xfrm>
+          <a:prstGeom prst="rect">
+            <a:avLst/>
+          </a:prstGeom>
+          <a:noFill/>
+        </p:spPr>
+        <p:txBody>
+          <a:bodyPr wrap="square">
+            <a:spAutoFit/>
+          </a:bodyPr>
+          <a:lstStyle/>
+          <a:p>
+            <a:pPr algn="l"/>
+            <a:r>
+              <a:rPr sz="2800" b="1">
+                <a:solidFill>
+                  <a:srgbClr val="FFFFFF"/>
+                </a:solidFill>
+              </a:rPr>
+              <a:t>File System and Storage Management</a:t>
+            </a:r>
+          </a:p>
+        </p:txBody>
+      </p:sp>
+      <p:sp>
+        <p:nvSpPr>
+          <p:cNvPr id="4" name="TextBox 3"/>
+          <p:cNvSpPr txBox="1"/>
+          <p:nvPr/>
+        </p:nvSpPr>
+        <p:spPr>
+          <a:xfrm>
+            <a:off x="365760" y="1005840"/>
+            <a:ext cx="5943600" cy="5303520"/>
+          </a:xfrm>
+          <a:prstGeom prst="rect">
+            <a:avLst/>
+          </a:prstGeom>
+          <a:noFill/>
+        </p:spPr>
+        <p:txBody>
+          <a:bodyPr wrap="square">
+            <a:spAutoFit/>
+          </a:bodyPr>
+          <a:lstStyle/>
+          <a:p>
+            <a:pPr algn="l"/>
+            <a:r>
+              <a:rPr sz="2200" b="0">
+                <a:solidFill>
+                  <a:srgbClr val="CAD3E0"/>
+                </a:solidFill>
+              </a:rPr>
+              <a:t>• File systems provide a hierarchical organization of data always
+• Storage devices such as disks and tapes store data persistently
+• File allocation methods optimize storage space utilization always
+• File protection and security mechanisms prevent unauthorized access
+• Disk scheduling algorithms optimize data retrieval and storage</a:t>
+            </a:r>
+          </a:p>
+        </p:txBody>
+      </p:sp>
+      <p:pic>
+        <p:nvPicPr>
+          <p:cNvPr id="5" name="Picture 4" descr="tmp5yxwu8aa.jpg"/>
+          <p:cNvPicPr>
+            <a:picLocks noChangeAspect="1"/>
+          </p:cNvPicPr>
+          <p:nvPr/>
+        </p:nvPicPr>
+        <p:blipFill>
+          <a:blip r:embed="rId2"/>
+          <a:stretch>
+            <a:fillRect/>
+          </a:stretch>
+        </p:blipFill>
+        <p:spPr>
+          <a:xfrm>
+            <a:off x="6583680" y="822960"/>
+            <a:ext cx="5212080" cy="5303520"/>
+          </a:xfrm>
+          <a:prstGeom prst="rect">
+            <a:avLst/>
+          </a:prstGeom>
+        </p:spPr>
+      </p:pic>
+    </p:spTree>
+  </p:cSld>
+  <p:clrMapOvr>
+    <a:masterClrMapping/>
+  </p:clrMapOvr>
+</p:sld>
+</file>
+
+<file path=ppt/slides/slide6.xml><?xml version="1.0" encoding="utf-8"?>
+<p:sld xmlns:a="http://schemas.openxmlformats.org/drawingml/2006/main" xmlns:p="http://schemas.openxmlformats.org/presentationml/2006/main" xmlns:r="http://schemas.openxmlformats.org/officeDocument/2006/relationships">
+  <p:cSld>
+    <p:bg>
+      <p:bgPr>
+        <a:solidFill>
+          <a:srgbClr val="0D1B2A"/>
+        </a:solidFill>
+        <a:effectLst/>
+      </p:bgPr>
+    </p:bg>
+    <p:spTree>
+      <p:nvGrpSpPr>
+        <p:cNvPr id="1" name=""/>
+        <p:cNvGrpSpPr/>
+        <p:nvPr/>
+      </p:nvGrpSpPr>
+      <p:grpSpPr/>
+      <p:sp>
+        <p:nvSpPr>
+          <p:cNvPr id="2" name="Rectangle 1"/>
+          <p:cNvSpPr/>
+          <p:nvPr/>
+        </p:nvSpPr>
+        <p:spPr>
+          <a:xfrm>
+            <a:off x="0" y="0"/>
+            <a:ext cx="12188952" cy="73152"/>
+          </a:xfrm>
+          <a:prstGeom prst="rect">
+            <a:avLst/>
+          </a:prstGeom>
+          <a:solidFill>
+            <a:srgbClr val="00B4D8"/>
+          </a:solidFill>
+          <a:ln>
+            <a:noFill/>
+          </a:ln>
+        </p:spPr>
+        <p:style>
+          <a:lnRef idx="1">
+            <a:schemeClr val="accent1"/>
+          </a:lnRef>
+          <a:fillRef idx="3">
+            <a:schemeClr val="accent1"/>
+          </a:fillRef>
+          <a:effectRef idx="2">
+            <a:schemeClr val="accent1"/>
+          </a:effectRef>
+          <a:fontRef idx="minor">
+            <a:schemeClr val="lt1"/>
+          </a:fontRef>
+        </p:style>
+        <p:txBody>
+          <a:bodyPr rtlCol="0" anchor="ctr"/>
+          <a:lstStyle/>
+          <a:p>
+            <a:pPr algn="ctr"/>
+          </a:p>
+        </p:txBody>
+      </p:sp>
+      <p:sp>
+        <p:nvSpPr>
+          <p:cNvPr id="3" name="TextBox 2"/>
+          <p:cNvSpPr txBox="1"/>
+          <p:nvPr/>
+        </p:nvSpPr>
+        <p:spPr>
+          <a:xfrm>
+            <a:off x="365760" y="137160"/>
+            <a:ext cx="6858000" cy="731520"/>
+          </a:xfrm>
+          <a:prstGeom prst="rect">
+            <a:avLst/>
+          </a:prstGeom>
+          <a:noFill/>
+        </p:spPr>
+        <p:txBody>
+          <a:bodyPr wrap="square">
+            <a:spAutoFit/>
+          </a:bodyPr>
+          <a:lstStyle/>
+          <a:p>
+            <a:pPr algn="l"/>
+            <a:r>
+              <a:rPr sz="2800" b="1">
+                <a:solidFill>
+                  <a:srgbClr val="FFFFFF"/>
+                </a:solidFill>
+              </a:rPr>
+              <a:t>Security and Networking Concepts</a:t>
+            </a:r>
+          </a:p>
+        </p:txBody>
+      </p:sp>
+      <p:sp>
+        <p:nvSpPr>
+          <p:cNvPr id="4" name="TextBox 3"/>
+          <p:cNvSpPr txBox="1"/>
+          <p:nvPr/>
+        </p:nvSpPr>
+        <p:spPr>
+          <a:xfrm>
+            <a:off x="365760" y="1005840"/>
+            <a:ext cx="5943600" cy="5303520"/>
+          </a:xfrm>
+          <a:prstGeom prst="rect">
+            <a:avLst/>
+          </a:prstGeom>
+          <a:noFill/>
+        </p:spPr>
+        <p:txBody>
+          <a:bodyPr wrap="square">
+            <a:spAutoFit/>
+          </a:bodyPr>
+          <a:lstStyle/>
+          <a:p>
+            <a:pPr algn="l"/>
+            <a:r>
+              <a:rPr sz="2200" b="0">
+                <a:solidFill>
+                  <a:srgbClr val="CAD3E0"/>
+                </a:solidFill>
+              </a:rPr>
+              <a:t>• Security mechanisms prevent unauthorized system access always
+• Firewalls and intrusion detection systems protect networks always
+• Networking protocols enable communication between devices always
+• Encryption methods secure data transmission and storage always
+• Access control mechanisms regulate user privileges effectively</a:t>
+            </a:r>
+          </a:p>
+        </p:txBody>
+      </p:sp>
+      <p:pic>
+        <p:nvPicPr>
+          <p:cNvPr id="5" name="Picture 4" descr="tmpnfarbn9o.jpg"/>
+          <p:cNvPicPr>
+            <a:picLocks noChangeAspect="1"/>
+          </p:cNvPicPr>
+          <p:nvPr/>
+        </p:nvPicPr>
+        <p:blipFill>
+          <a:blip r:embed="rId2"/>
+          <a:stretch>
+            <a:fillRect/>
+          </a:stretch>
+        </p:blipFill>
+        <p:spPr>
+          <a:xfrm>
+            <a:off x="6583680" y="822960"/>
+            <a:ext cx="5212080" cy="5303520"/>
+          </a:xfrm>
+          <a:prstGeom prst="rect">
+            <a:avLst/>
+          </a:prstGeom>
+        </p:spPr>
+      </p:pic>
+    </p:spTree>
+  </p:cSld>
+  <p:clrMapOvr>
+    <a:masterClrMapping/>
+  </p:clrMapOvr>
+</p:sld>
+</file>
+
+<file path=ppt/slides/slide7.xml><?xml version="1.0" encoding="utf-8"?>
+<p:sld xmlns:a="http://schemas.openxmlformats.org/drawingml/2006/main" xmlns:p="http://schemas.openxmlformats.org/presentationml/2006/main" xmlns:r="http://schemas.openxmlformats.org/officeDocument/2006/relationships">
+  <p:cSld>
+    <p:bg>
+      <p:bgPr>
+        <a:solidFill>
+          <a:srgbClr val="0D1B2A"/>
+        </a:solidFill>
+        <a:effectLst/>
+      </p:bgPr>
+    </p:bg>
+    <p:spTree>
+      <p:nvGrpSpPr>
+        <p:cNvPr id="1" name=""/>
+        <p:cNvGrpSpPr/>
+        <p:nvPr/>
+      </p:nvGrpSpPr>
+      <p:grpSpPr/>
+      <p:sp>
+        <p:nvSpPr>
+          <p:cNvPr id="2" name="Rectangle 1"/>
+          <p:cNvSpPr/>
+          <p:nvPr/>
+        </p:nvSpPr>
+        <p:spPr>
+          <a:xfrm>
+            <a:off x="0" y="6784848"/>
+            <a:ext cx="12188952" cy="73152"/>
+          </a:xfrm>
+          <a:prstGeom prst="rect">
+            <a:avLst/>
+          </a:prstGeom>
+          <a:solidFill>
+            <a:srgbClr val="00B4D8"/>
+          </a:solidFill>
+          <a:ln>
+            <a:noFill/>
+          </a:ln>
+        </p:spPr>
+        <p:style>
+          <a:lnRef idx="1">
+            <a:schemeClr val="accent1"/>
+          </a:lnRef>
+          <a:fillRef idx="3">
+            <a:schemeClr val="accent1"/>
+          </a:fillRef>
+          <a:effectRef idx="2">
+            <a:schemeClr val="accent1"/>
+          </a:effectRef>
+          <a:fontRef idx="minor">
+            <a:schemeClr val="lt1"/>
+          </a:fontRef>
+        </p:style>
+        <p:txBody>
+          <a:bodyPr rtlCol="0" anchor="ctr"/>
+          <a:lstStyle/>
+          <a:p>
+            <a:pPr algn="ctr"/>
+          </a:p>
+        </p:txBody>
+      </p:sp>
+      <p:sp>
+        <p:nvSpPr>
+          <p:cNvPr id="3" name="TextBox 2"/>
+          <p:cNvSpPr txBox="1"/>
+          <p:nvPr/>
+        </p:nvSpPr>
+        <p:spPr>
+          <a:xfrm>
+            <a:off x="457200" y="274320"/>
+            <a:ext cx="10972800" cy="822960"/>
+          </a:xfrm>
+          <a:prstGeom prst="rect">
+            <a:avLst/>
+          </a:prstGeom>
+          <a:noFill/>
+        </p:spPr>
+        <p:txBody>
+          <a:bodyPr wrap="square">
+            <a:spAutoFit/>
+          </a:bodyPr>
+          <a:lstStyle/>
+          <a:p>
+            <a:pPr algn="ctr"/>
+            <a:r>
+              <a:rPr sz="3600" b="1">
+                <a:solidFill>
+                  <a:srgbClr val="FFFFFF"/>
+                </a:solidFill>
+              </a:rPr>
+              <a:t>Conclusion</a:t>
+            </a:r>
+          </a:p>
+        </p:txBody>
+      </p:sp>
+      <p:sp>
+        <p:nvSpPr>
+          <p:cNvPr id="4" name="TextBox 3"/>
+          <p:cNvSpPr txBox="1"/>
+          <p:nvPr/>
+        </p:nvSpPr>
+        <p:spPr>
+          <a:xfrm>
+            <a:off x="914400" y="1280160"/>
+            <a:ext cx="10058400" cy="914400"/>
+          </a:xfrm>
+          <a:prstGeom prst="rect">
+            <a:avLst/>
+          </a:prstGeom>
+          <a:noFill/>
+        </p:spPr>
+        <p:txBody>
+          <a:bodyPr wrap="square">
+            <a:spAutoFit/>
+          </a:bodyPr>
+          <a:lstStyle/>
+          <a:p>
+            <a:pPr algn="ctr"/>
+            <a:r>
+              <a:rPr sz="1900" b="0">
+                <a:solidFill>
+                  <a:srgbClr val="00B4D8"/>
+                </a:solidFill>
+              </a:rPr>
+              <a:t>Operating system concepts are fundamental to understanding computer systems</a:t>
+            </a:r>
+          </a:p>
+        </p:txBody>
+      </p:sp>
+      <p:sp>
+        <p:nvSpPr>
+          <p:cNvPr id="5" name="TextBox 4"/>
+          <p:cNvSpPr txBox="1"/>
+          <p:nvPr/>
+        </p:nvSpPr>
+        <p:spPr>
+          <a:xfrm>
+            <a:off x="1828800" y="2377440"/>
+            <a:ext cx="8229600" cy="3200400"/>
+          </a:xfrm>
+          <a:prstGeom prst="rect">
+            <a:avLst/>
+          </a:prstGeom>
+          <a:noFill/>
+        </p:spPr>
+        <p:txBody>
+          <a:bodyPr wrap="square">
+            <a:spAutoFit/>
+          </a:bodyPr>
+          <a:lstStyle/>
+          <a:p>
+            <a:pPr algn="l"/>
+            <a:r>
+              <a:rPr sz="1800" b="0">
+                <a:solidFill>
+                  <a:srgbClr val="CAD3E0"/>
+                </a:solidFill>
+              </a:rPr>
+              <a:t>  process management
+  memory management
+  file system management</a:t>
             </a:r>
           </a:p>
         </p:txBody>

</xml_diff>